<commit_message>
resources: add icons files
</commit_message>
<xml_diff>
--- a/assets/icons-template/128x128 - Chrome Web Store.pptx
+++ b/assets/icons-template/128x128 - Chrome Web Store.pptx
@@ -3009,10 +3009,10 @@
           <a:gradFill flip="none" rotWithShape="1">
             <a:gsLst>
               <a:gs pos="0">
-                <a:srgbClr val="FF2D47"/>
+                <a:srgbClr val="B7C0FF"/>
               </a:gs>
               <a:gs pos="100000">
-                <a:srgbClr val="FF593A"/>
+                <a:srgbClr val="B8BFFF"/>
               </a:gs>
             </a:gsLst>
             <a:lin ang="5400000" scaled="1"/>
@@ -3141,6 +3141,42 @@
           </a:p>
         </p:txBody>
       </p:sp>
+      <p:pic>
+        <p:nvPicPr>
+          <p:cNvPr id="3" name="Gráfico 2" descr="Sincronização com a nuvem com preenchimento sólido">
+            <a:extLst>
+              <a:ext uri="{FF2B5EF4-FFF2-40B4-BE49-F238E27FC236}">
+                <a16:creationId xmlns:a16="http://schemas.microsoft.com/office/drawing/2014/main" id="{4C38B9DC-07AF-AB16-74DD-17C312A2F0D8}"/>
+              </a:ext>
+            </a:extLst>
+          </p:cNvPr>
+          <p:cNvPicPr>
+            <a:picLocks noChangeAspect="1"/>
+          </p:cNvPicPr>
+          <p:nvPr/>
+        </p:nvPicPr>
+        <p:blipFill>
+          <a:blip r:embed="rId2">
+            <a:extLst>
+              <a:ext uri="{96DAC541-7B7A-43D3-8B79-37D633B846F1}">
+                <asvg:svgBlip xmlns:asvg="http://schemas.microsoft.com/office/drawing/2016/SVG/main" r:embed="rId3"/>
+              </a:ext>
+            </a:extLst>
+          </a:blip>
+          <a:stretch>
+            <a:fillRect/>
+          </a:stretch>
+        </p:blipFill>
+        <p:spPr>
+          <a:xfrm>
+            <a:off x="960847" y="-2004873"/>
+            <a:ext cx="44158668" cy="44158668"/>
+          </a:xfrm>
+          <a:prstGeom prst="rect">
+            <a:avLst/>
+          </a:prstGeom>
+        </p:spPr>
+      </p:pic>
     </p:spTree>
     <p:extLst>
       <p:ext uri="{BB962C8B-B14F-4D97-AF65-F5344CB8AC3E}">

</xml_diff>